<commit_message>
chore: mark project lab completion checkpoint
</commit_message>
<xml_diff>
--- a/docs/Presentation/MyHR_Project_Lab_Presentation.pptx
+++ b/docs/Presentation/MyHR_Project_Lab_Presentation.pptx
@@ -3321,8 +3321,8 @@
         </p:nvSpPr>
         <p:spPr>
           <a:xfrm>
-            <a:off x="731520" y="1737360"/>
-            <a:ext cx="7315200" cy="2194560"/>
+            <a:off x="731520" y="1338942"/>
+            <a:ext cx="7315200" cy="2978331"/>
           </a:xfrm>
           <a:prstGeom prst="rect">
             <a:avLst/>
@@ -3486,19 +3486,6 @@
               </a:rPr>
               <a:t>Desktop application packaging and deployment</a:t>
             </a:r>
-          </a:p>
-          <a:p>
-            <a:pPr marL="342900" indent="-342900">
-              <a:lnSpc>
-                <a:spcPct val="150000"/>
-              </a:lnSpc>
-              <a:spcAft>
-                <a:spcPts val="600"/>
-              </a:spcAft>
-              <a:buSzPct val="100000"/>
-              <a:buChar char="•"/>
-            </a:pPr>
-            <a:endParaRPr lang="en-US" sz="1400" dirty="0"/>
           </a:p>
         </p:txBody>
       </p:sp>
@@ -5353,8 +5340,10 @@
           <a:bodyPr wrap="square" rtlCol="0" anchor="t"/>
           <a:lstStyle/>
           <a:p>
-            <a:pPr>
+            <a:pPr marL="171450" indent="-171450">
               <a:buSzPct val="100000"/>
+              <a:buFont typeface="Arial" panose="020B0604020202020204" pitchFamily="34" charset="0"/>
+              <a:buChar char="•"/>
             </a:pPr>
             <a:r>
               <a:rPr lang="en-US" sz="1200" b="1" dirty="0">
@@ -5393,8 +5382,10 @@
             </a:endParaRPr>
           </a:p>
           <a:p>
-            <a:pPr>
+            <a:pPr marL="171450" indent="-171450">
               <a:buSzPct val="100000"/>
+              <a:buFont typeface="Arial" panose="020B0604020202020204" pitchFamily="34" charset="0"/>
+              <a:buChar char="•"/>
             </a:pPr>
             <a:r>
               <a:rPr lang="en-US" sz="1200" b="1" dirty="0">
@@ -5420,8 +5411,10 @@
             </a:endParaRPr>
           </a:p>
           <a:p>
-            <a:pPr>
+            <a:pPr marL="171450" indent="-171450">
               <a:buSzPct val="100000"/>
+              <a:buFont typeface="Arial" panose="020B0604020202020204" pitchFamily="34" charset="0"/>
+              <a:buChar char="•"/>
             </a:pPr>
             <a:r>
               <a:rPr lang="en-US" sz="1200" b="1" dirty="0">
@@ -5447,8 +5440,10 @@
             </a:endParaRPr>
           </a:p>
           <a:p>
-            <a:pPr>
+            <a:pPr marL="171450" indent="-171450">
               <a:buSzPct val="100000"/>
+              <a:buFont typeface="Arial" panose="020B0604020202020204" pitchFamily="34" charset="0"/>
+              <a:buChar char="•"/>
             </a:pPr>
             <a:r>
               <a:rPr lang="en-US" sz="1200" b="1" dirty="0">
@@ -6248,7 +6243,7 @@
         </p:nvSpPr>
         <p:spPr>
           <a:xfrm>
-            <a:off x="889000" y="1781176"/>
+            <a:off x="901700" y="1694046"/>
             <a:ext cx="1778000" cy="1107996"/>
           </a:xfrm>
           <a:prstGeom prst="rect">

</xml_diff>